<commit_message>
fix: update card images
</commit_message>
<xml_diff>
--- a/public/static/cardImages/card_design.pptx
+++ b/public/static/cardImages/card_design.pptx
@@ -39,6 +39,8 @@
     <p:sldId id="288" r:id="rId33"/>
     <p:sldId id="289" r:id="rId34"/>
     <p:sldId id="290" r:id="rId35"/>
+    <p:sldId id="292" r:id="rId36"/>
+    <p:sldId id="293" r:id="rId37"/>
   </p:sldIdLst>
   <p:sldSz cx="12192000" cy="6858000"/>
   <p:notesSz cx="6858000" cy="9144000"/>
@@ -292,7 +294,7 @@
           <a:p>
             <a:fld id="{EB365587-9C4C-414F-A385-CCAE61E11FA3}" type="datetimeFigureOut">
               <a:rPr lang="en-US" smtClean="0"/>
-              <a:t>4/11/2026</a:t>
+              <a:t>9/14/2026</a:t>
             </a:fld>
             <a:endParaRPr lang="en-US"/>
           </a:p>
@@ -490,7 +492,7 @@
           <a:p>
             <a:fld id="{EB365587-9C4C-414F-A385-CCAE61E11FA3}" type="datetimeFigureOut">
               <a:rPr lang="en-US" smtClean="0"/>
-              <a:t>4/11/2026</a:t>
+              <a:t>9/14/2026</a:t>
             </a:fld>
             <a:endParaRPr lang="en-US"/>
           </a:p>
@@ -698,7 +700,7 @@
           <a:p>
             <a:fld id="{EB365587-9C4C-414F-A385-CCAE61E11FA3}" type="datetimeFigureOut">
               <a:rPr lang="en-US" smtClean="0"/>
-              <a:t>4/11/2026</a:t>
+              <a:t>9/14/2026</a:t>
             </a:fld>
             <a:endParaRPr lang="en-US"/>
           </a:p>
@@ -896,7 +898,7 @@
           <a:p>
             <a:fld id="{EB365587-9C4C-414F-A385-CCAE61E11FA3}" type="datetimeFigureOut">
               <a:rPr lang="en-US" smtClean="0"/>
-              <a:t>4/11/2026</a:t>
+              <a:t>9/14/2026</a:t>
             </a:fld>
             <a:endParaRPr lang="en-US"/>
           </a:p>
@@ -1171,7 +1173,7 @@
           <a:p>
             <a:fld id="{EB365587-9C4C-414F-A385-CCAE61E11FA3}" type="datetimeFigureOut">
               <a:rPr lang="en-US" smtClean="0"/>
-              <a:t>4/11/2026</a:t>
+              <a:t>9/14/2026</a:t>
             </a:fld>
             <a:endParaRPr lang="en-US"/>
           </a:p>
@@ -1436,7 +1438,7 @@
           <a:p>
             <a:fld id="{EB365587-9C4C-414F-A385-CCAE61E11FA3}" type="datetimeFigureOut">
               <a:rPr lang="en-US" smtClean="0"/>
-              <a:t>4/11/2026</a:t>
+              <a:t>9/14/2026</a:t>
             </a:fld>
             <a:endParaRPr lang="en-US"/>
           </a:p>
@@ -1848,7 +1850,7 @@
           <a:p>
             <a:fld id="{EB365587-9C4C-414F-A385-CCAE61E11FA3}" type="datetimeFigureOut">
               <a:rPr lang="en-US" smtClean="0"/>
-              <a:t>4/11/2026</a:t>
+              <a:t>9/14/2026</a:t>
             </a:fld>
             <a:endParaRPr lang="en-US"/>
           </a:p>
@@ -1989,7 +1991,7 @@
           <a:p>
             <a:fld id="{EB365587-9C4C-414F-A385-CCAE61E11FA3}" type="datetimeFigureOut">
               <a:rPr lang="en-US" smtClean="0"/>
-              <a:t>4/11/2026</a:t>
+              <a:t>9/14/2026</a:t>
             </a:fld>
             <a:endParaRPr lang="en-US"/>
           </a:p>
@@ -2102,7 +2104,7 @@
           <a:p>
             <a:fld id="{EB365587-9C4C-414F-A385-CCAE61E11FA3}" type="datetimeFigureOut">
               <a:rPr lang="en-US" smtClean="0"/>
-              <a:t>4/11/2026</a:t>
+              <a:t>9/14/2026</a:t>
             </a:fld>
             <a:endParaRPr lang="en-US"/>
           </a:p>
@@ -2413,7 +2415,7 @@
           <a:p>
             <a:fld id="{EB365587-9C4C-414F-A385-CCAE61E11FA3}" type="datetimeFigureOut">
               <a:rPr lang="en-US" smtClean="0"/>
-              <a:t>4/11/2026</a:t>
+              <a:t>9/14/2026</a:t>
             </a:fld>
             <a:endParaRPr lang="en-US"/>
           </a:p>
@@ -2701,7 +2703,7 @@
           <a:p>
             <a:fld id="{EB365587-9C4C-414F-A385-CCAE61E11FA3}" type="datetimeFigureOut">
               <a:rPr lang="en-US" smtClean="0"/>
-              <a:t>4/11/2026</a:t>
+              <a:t>9/14/2026</a:t>
             </a:fld>
             <a:endParaRPr lang="en-US"/>
           </a:p>
@@ -2942,7 +2944,7 @@
           <a:p>
             <a:fld id="{EB365587-9C4C-414F-A385-CCAE61E11FA3}" type="datetimeFigureOut">
               <a:rPr lang="en-US" smtClean="0"/>
-              <a:t>4/11/2026</a:t>
+              <a:t>9/14/2026</a:t>
             </a:fld>
             <a:endParaRPr lang="en-US"/>
           </a:p>
@@ -3694,11 +3696,17 @@
         </p:nvGrpSpPr>
         <p:grpSpPr>
           <a:xfrm>
-            <a:off x="4517574" y="601937"/>
-            <a:ext cx="3603172" cy="5025978"/>
-            <a:chOff x="4517574" y="601937"/>
-            <a:chExt cx="3603172" cy="5025978"/>
+            <a:off x="4517574" y="696688"/>
+            <a:ext cx="3603172" cy="4931227"/>
+            <a:chOff x="4517574" y="696688"/>
+            <a:chExt cx="3603172" cy="4931227"/>
           </a:xfrm>
+          <a:solidFill>
+            <a:schemeClr val="tx2">
+              <a:lumMod val="50000"/>
+              <a:lumOff val="50000"/>
+            </a:schemeClr>
+          </a:solidFill>
         </p:grpSpPr>
         <p:sp>
           <p:nvSpPr>
@@ -3720,12 +3728,7 @@
             <a:prstGeom prst="rect">
               <a:avLst/>
             </a:prstGeom>
-            <a:solidFill>
-              <a:schemeClr val="accent5">
-                <a:lumMod val="60000"/>
-                <a:lumOff val="40000"/>
-              </a:schemeClr>
-            </a:solidFill>
+            <a:grpFill/>
           </p:spPr>
           <p:style>
             <a:lnRef idx="2">
@@ -3821,43 +3824,6 @@
         </p:sp>
         <p:sp>
           <p:nvSpPr>
-            <p:cNvPr id="3" name="TextBox 2">
-              <a:extLst>
-                <a:ext uri="{FF2B5EF4-FFF2-40B4-BE49-F238E27FC236}">
-                  <a16:creationId xmlns:a16="http://schemas.microsoft.com/office/drawing/2014/main" id="{2CB37C12-D869-E963-4EBF-A1CE115D71CC}"/>
-                </a:ext>
-              </a:extLst>
-            </p:cNvPr>
-            <p:cNvSpPr txBox="1"/>
-            <p:nvPr/>
-          </p:nvSpPr>
-          <p:spPr>
-            <a:xfrm>
-              <a:off x="7294878" y="601937"/>
-              <a:ext cx="825867" cy="1015343"/>
-            </a:xfrm>
-            <a:prstGeom prst="rect">
-              <a:avLst/>
-            </a:prstGeom>
-            <a:noFill/>
-          </p:spPr>
-          <p:txBody>
-            <a:bodyPr wrap="none" rtlCol="0">
-              <a:spAutoFit/>
-            </a:bodyPr>
-            <a:lstStyle/>
-            <a:p>
-              <a:r>
-                <a:rPr lang="en-US" sz="5998" b="1" dirty="0">
-                  <a:latin typeface="Arial Rounded MT Bold" panose="020F0704030504030204" pitchFamily="34" charset="0"/>
-                </a:rPr>
-                <a:t>M</a:t>
-              </a:r>
-            </a:p>
-          </p:txBody>
-        </p:sp>
-        <p:sp>
-          <p:nvSpPr>
             <p:cNvPr id="9" name="TextBox 8">
               <a:extLst>
                 <a:ext uri="{FF2B5EF4-FFF2-40B4-BE49-F238E27FC236}">
@@ -3876,7 +3842,7 @@
             <a:prstGeom prst="rect">
               <a:avLst/>
             </a:prstGeom>
-            <a:noFill/>
+            <a:grpFill/>
           </p:spPr>
           <p:txBody>
             <a:bodyPr wrap="none" rtlCol="0">
@@ -3938,7 +3904,7 @@
             <a:prstGeom prst="rect">
               <a:avLst/>
             </a:prstGeom>
-            <a:noFill/>
+            <a:grpFill/>
             <a:extLst>
               <a:ext uri="{909E8E84-426E-40DD-AFC4-6F175D3DCCD1}">
                 <a14:hiddenFill xmlns:a14="http://schemas.microsoft.com/office/drawing/2010/main">
@@ -4011,11 +3977,17 @@
         </p:nvGrpSpPr>
         <p:grpSpPr>
           <a:xfrm>
-            <a:off x="4517574" y="601937"/>
-            <a:ext cx="3603172" cy="5025978"/>
-            <a:chOff x="4517574" y="601937"/>
-            <a:chExt cx="3603172" cy="5025978"/>
+            <a:off x="4517574" y="696688"/>
+            <a:ext cx="3603172" cy="4931227"/>
+            <a:chOff x="4517574" y="696688"/>
+            <a:chExt cx="3603172" cy="4931227"/>
           </a:xfrm>
+          <a:solidFill>
+            <a:schemeClr val="tx2">
+              <a:lumMod val="50000"/>
+              <a:lumOff val="50000"/>
+            </a:schemeClr>
+          </a:solidFill>
         </p:grpSpPr>
         <p:sp>
           <p:nvSpPr>
@@ -4037,12 +4009,7 @@
             <a:prstGeom prst="rect">
               <a:avLst/>
             </a:prstGeom>
-            <a:solidFill>
-              <a:schemeClr val="accent5">
-                <a:lumMod val="60000"/>
-                <a:lumOff val="40000"/>
-              </a:schemeClr>
-            </a:solidFill>
+            <a:grpFill/>
           </p:spPr>
           <p:style>
             <a:lnRef idx="2">
@@ -4138,43 +4105,6 @@
         </p:sp>
         <p:sp>
           <p:nvSpPr>
-            <p:cNvPr id="3" name="TextBox 2">
-              <a:extLst>
-                <a:ext uri="{FF2B5EF4-FFF2-40B4-BE49-F238E27FC236}">
-                  <a16:creationId xmlns:a16="http://schemas.microsoft.com/office/drawing/2014/main" id="{8A4C070C-CC45-F798-DDF1-61054091EFA0}"/>
-                </a:ext>
-              </a:extLst>
-            </p:cNvPr>
-            <p:cNvSpPr txBox="1"/>
-            <p:nvPr/>
-          </p:nvSpPr>
-          <p:spPr>
-            <a:xfrm>
-              <a:off x="7294878" y="601937"/>
-              <a:ext cx="825867" cy="1015343"/>
-            </a:xfrm>
-            <a:prstGeom prst="rect">
-              <a:avLst/>
-            </a:prstGeom>
-            <a:noFill/>
-          </p:spPr>
-          <p:txBody>
-            <a:bodyPr wrap="none" rtlCol="0">
-              <a:spAutoFit/>
-            </a:bodyPr>
-            <a:lstStyle/>
-            <a:p>
-              <a:r>
-                <a:rPr lang="en-US" sz="5998" b="1" dirty="0">
-                  <a:latin typeface="Arial Rounded MT Bold" panose="020F0704030504030204" pitchFamily="34" charset="0"/>
-                </a:rPr>
-                <a:t>M</a:t>
-              </a:r>
-            </a:p>
-          </p:txBody>
-        </p:sp>
-        <p:sp>
-          <p:nvSpPr>
             <p:cNvPr id="9" name="TextBox 8">
               <a:extLst>
                 <a:ext uri="{FF2B5EF4-FFF2-40B4-BE49-F238E27FC236}">
@@ -4193,7 +4123,7 @@
             <a:prstGeom prst="rect">
               <a:avLst/>
             </a:prstGeom>
-            <a:noFill/>
+            <a:grpFill/>
           </p:spPr>
           <p:txBody>
             <a:bodyPr wrap="none" rtlCol="0">
@@ -4246,7 +4176,7 @@
             <a:prstGeom prst="rect">
               <a:avLst/>
             </a:prstGeom>
-            <a:noFill/>
+            <a:grpFill/>
             <a:extLst>
               <a:ext uri="{909E8E84-426E-40DD-AFC4-6F175D3DCCD1}">
                 <a14:hiddenFill xmlns:a14="http://schemas.microsoft.com/office/drawing/2010/main">
@@ -4326,9 +4256,9 @@
             <a:avLst/>
           </a:prstGeom>
           <a:solidFill>
-            <a:schemeClr val="accent5">
-              <a:lumMod val="60000"/>
-              <a:lumOff val="40000"/>
+            <a:schemeClr val="tx2">
+              <a:lumMod val="50000"/>
+              <a:lumOff val="50000"/>
             </a:schemeClr>
           </a:solidFill>
         </p:spPr>
@@ -4421,43 +4351,6 @@
               <a:latin typeface="Arial Rounded MT Bold" panose="020F0704030504030204" pitchFamily="34" charset="0"/>
               <a:ea typeface="Segoe UI Symbol" panose="020B0502040204020203" pitchFamily="34" charset="0"/>
             </a:endParaRPr>
-          </a:p>
-        </p:txBody>
-      </p:sp>
-      <p:sp>
-        <p:nvSpPr>
-          <p:cNvPr id="3" name="TextBox 2">
-            <a:extLst>
-              <a:ext uri="{FF2B5EF4-FFF2-40B4-BE49-F238E27FC236}">
-                <a16:creationId xmlns:a16="http://schemas.microsoft.com/office/drawing/2014/main" id="{FBC254D6-20E5-BB44-9BD3-96187E2859A7}"/>
-              </a:ext>
-            </a:extLst>
-          </p:cNvPr>
-          <p:cNvSpPr txBox="1"/>
-          <p:nvPr/>
-        </p:nvSpPr>
-        <p:spPr>
-          <a:xfrm>
-            <a:off x="7294878" y="601937"/>
-            <a:ext cx="825867" cy="1015343"/>
-          </a:xfrm>
-          <a:prstGeom prst="rect">
-            <a:avLst/>
-          </a:prstGeom>
-          <a:noFill/>
-        </p:spPr>
-        <p:txBody>
-          <a:bodyPr wrap="none" rtlCol="0">
-            <a:spAutoFit/>
-          </a:bodyPr>
-          <a:lstStyle/>
-          <a:p>
-            <a:r>
-              <a:rPr lang="en-US" sz="5998" b="1" dirty="0">
-                <a:latin typeface="Arial Rounded MT Bold" panose="020F0704030504030204" pitchFamily="34" charset="0"/>
-              </a:rPr>
-              <a:t>M</a:t>
-            </a:r>
           </a:p>
         </p:txBody>
       </p:sp>
@@ -4624,9 +4517,9 @@
             <a:avLst/>
           </a:prstGeom>
           <a:solidFill>
-            <a:schemeClr val="accent5">
-              <a:lumMod val="60000"/>
-              <a:lumOff val="40000"/>
+            <a:schemeClr val="tx2">
+              <a:lumMod val="50000"/>
+              <a:lumOff val="50000"/>
             </a:schemeClr>
           </a:solidFill>
         </p:spPr>
@@ -4719,43 +4612,6 @@
               <a:latin typeface="Arial Rounded MT Bold" panose="020F0704030504030204" pitchFamily="34" charset="0"/>
               <a:ea typeface="Segoe UI Symbol" panose="020B0502040204020203" pitchFamily="34" charset="0"/>
             </a:endParaRPr>
-          </a:p>
-        </p:txBody>
-      </p:sp>
-      <p:sp>
-        <p:nvSpPr>
-          <p:cNvPr id="3" name="TextBox 2">
-            <a:extLst>
-              <a:ext uri="{FF2B5EF4-FFF2-40B4-BE49-F238E27FC236}">
-                <a16:creationId xmlns:a16="http://schemas.microsoft.com/office/drawing/2014/main" id="{0EBB5A03-A7EE-A7BF-15E7-0E76C74E70C6}"/>
-              </a:ext>
-            </a:extLst>
-          </p:cNvPr>
-          <p:cNvSpPr txBox="1"/>
-          <p:nvPr/>
-        </p:nvSpPr>
-        <p:spPr>
-          <a:xfrm>
-            <a:off x="7294878" y="601937"/>
-            <a:ext cx="825867" cy="1015343"/>
-          </a:xfrm>
-          <a:prstGeom prst="rect">
-            <a:avLst/>
-          </a:prstGeom>
-          <a:noFill/>
-        </p:spPr>
-        <p:txBody>
-          <a:bodyPr wrap="none" rtlCol="0">
-            <a:spAutoFit/>
-          </a:bodyPr>
-          <a:lstStyle/>
-          <a:p>
-            <a:r>
-              <a:rPr lang="en-US" sz="5998" b="1" dirty="0">
-                <a:latin typeface="Arial Rounded MT Bold" panose="020F0704030504030204" pitchFamily="34" charset="0"/>
-              </a:rPr>
-              <a:t>M</a:t>
-            </a:r>
           </a:p>
         </p:txBody>
       </p:sp>
@@ -4934,11 +4790,17 @@
         </p:nvGrpSpPr>
         <p:grpSpPr>
           <a:xfrm>
-            <a:off x="4517574" y="601937"/>
-            <a:ext cx="3603172" cy="5025978"/>
-            <a:chOff x="4517574" y="601937"/>
-            <a:chExt cx="3603172" cy="5025978"/>
+            <a:off x="4517574" y="696688"/>
+            <a:ext cx="3603172" cy="4931227"/>
+            <a:chOff x="4517574" y="696688"/>
+            <a:chExt cx="3603172" cy="4931227"/>
           </a:xfrm>
+          <a:solidFill>
+            <a:schemeClr val="tx2">
+              <a:lumMod val="50000"/>
+              <a:lumOff val="50000"/>
+            </a:schemeClr>
+          </a:solidFill>
         </p:grpSpPr>
         <p:sp>
           <p:nvSpPr>
@@ -4960,9 +4822,7 @@
             <a:prstGeom prst="rect">
               <a:avLst/>
             </a:prstGeom>
-            <a:solidFill>
-              <a:srgbClr val="FFC000"/>
-            </a:solidFill>
+            <a:grpFill/>
           </p:spPr>
           <p:style>
             <a:lnRef idx="2">
@@ -5058,43 +4918,6 @@
         </p:sp>
         <p:sp>
           <p:nvSpPr>
-            <p:cNvPr id="3" name="TextBox 2">
-              <a:extLst>
-                <a:ext uri="{FF2B5EF4-FFF2-40B4-BE49-F238E27FC236}">
-                  <a16:creationId xmlns:a16="http://schemas.microsoft.com/office/drawing/2014/main" id="{71796126-9DCB-BEFB-4B1B-EC96E895ED22}"/>
-                </a:ext>
-              </a:extLst>
-            </p:cNvPr>
-            <p:cNvSpPr txBox="1"/>
-            <p:nvPr/>
-          </p:nvSpPr>
-          <p:spPr>
-            <a:xfrm>
-              <a:off x="7294878" y="601937"/>
-              <a:ext cx="713657" cy="1015343"/>
-            </a:xfrm>
-            <a:prstGeom prst="rect">
-              <a:avLst/>
-            </a:prstGeom>
-            <a:noFill/>
-          </p:spPr>
-          <p:txBody>
-            <a:bodyPr wrap="none" rtlCol="0">
-              <a:spAutoFit/>
-            </a:bodyPr>
-            <a:lstStyle/>
-            <a:p>
-              <a:r>
-                <a:rPr lang="en-US" sz="5998" b="1" dirty="0">
-                  <a:latin typeface="Arial Rounded MT Bold" panose="020F0704030504030204" pitchFamily="34" charset="0"/>
-                </a:rPr>
-                <a:t>V</a:t>
-              </a:r>
-            </a:p>
-          </p:txBody>
-        </p:sp>
-        <p:sp>
-          <p:nvSpPr>
             <p:cNvPr id="9" name="TextBox 8">
               <a:extLst>
                 <a:ext uri="{FF2B5EF4-FFF2-40B4-BE49-F238E27FC236}">
@@ -5113,7 +4936,7 @@
             <a:prstGeom prst="rect">
               <a:avLst/>
             </a:prstGeom>
-            <a:noFill/>
+            <a:grpFill/>
           </p:spPr>
           <p:txBody>
             <a:bodyPr wrap="none" rtlCol="0">
@@ -5166,16 +4989,7 @@
             <a:prstGeom prst="rect">
               <a:avLst/>
             </a:prstGeom>
-            <a:noFill/>
-            <a:extLst>
-              <a:ext uri="{909E8E84-426E-40DD-AFC4-6F175D3DCCD1}">
-                <a14:hiddenFill xmlns:a14="http://schemas.microsoft.com/office/drawing/2010/main">
-                  <a:solidFill>
-                    <a:srgbClr val="FFFFFF"/>
-                  </a:solidFill>
-                </a14:hiddenFill>
-              </a:ext>
-            </a:extLst>
+            <a:grpFill/>
           </p:spPr>
         </p:pic>
       </p:grpSp>
@@ -5239,11 +5053,17 @@
         </p:nvGrpSpPr>
         <p:grpSpPr>
           <a:xfrm>
-            <a:off x="4517574" y="601937"/>
-            <a:ext cx="3603172" cy="5025978"/>
-            <a:chOff x="4517574" y="601937"/>
-            <a:chExt cx="3603172" cy="5025978"/>
+            <a:off x="4517574" y="696688"/>
+            <a:ext cx="3603172" cy="4931227"/>
+            <a:chOff x="4517574" y="696688"/>
+            <a:chExt cx="3603172" cy="4931227"/>
           </a:xfrm>
+          <a:solidFill>
+            <a:schemeClr val="tx2">
+              <a:lumMod val="50000"/>
+              <a:lumOff val="50000"/>
+            </a:schemeClr>
+          </a:solidFill>
         </p:grpSpPr>
         <p:sp>
           <p:nvSpPr>
@@ -5265,9 +5085,7 @@
             <a:prstGeom prst="rect">
               <a:avLst/>
             </a:prstGeom>
-            <a:solidFill>
-              <a:srgbClr val="FFC000"/>
-            </a:solidFill>
+            <a:grpFill/>
           </p:spPr>
           <p:style>
             <a:lnRef idx="2">
@@ -5363,43 +5181,6 @@
         </p:sp>
         <p:sp>
           <p:nvSpPr>
-            <p:cNvPr id="3" name="TextBox 2">
-              <a:extLst>
-                <a:ext uri="{FF2B5EF4-FFF2-40B4-BE49-F238E27FC236}">
-                  <a16:creationId xmlns:a16="http://schemas.microsoft.com/office/drawing/2014/main" id="{D9F3A611-ACE9-2A47-8F31-A8BC41DB77D8}"/>
-                </a:ext>
-              </a:extLst>
-            </p:cNvPr>
-            <p:cNvSpPr txBox="1"/>
-            <p:nvPr/>
-          </p:nvSpPr>
-          <p:spPr>
-            <a:xfrm>
-              <a:off x="7294878" y="601937"/>
-              <a:ext cx="713657" cy="1015343"/>
-            </a:xfrm>
-            <a:prstGeom prst="rect">
-              <a:avLst/>
-            </a:prstGeom>
-            <a:noFill/>
-          </p:spPr>
-          <p:txBody>
-            <a:bodyPr wrap="none" rtlCol="0">
-              <a:spAutoFit/>
-            </a:bodyPr>
-            <a:lstStyle/>
-            <a:p>
-              <a:r>
-                <a:rPr lang="en-US" sz="5998" b="1" dirty="0">
-                  <a:latin typeface="Arial Rounded MT Bold" panose="020F0704030504030204" pitchFamily="34" charset="0"/>
-                </a:rPr>
-                <a:t>V</a:t>
-              </a:r>
-            </a:p>
-          </p:txBody>
-        </p:sp>
-        <p:sp>
-          <p:nvSpPr>
             <p:cNvPr id="9" name="TextBox 8">
               <a:extLst>
                 <a:ext uri="{FF2B5EF4-FFF2-40B4-BE49-F238E27FC236}">
@@ -5418,7 +5199,7 @@
             <a:prstGeom prst="rect">
               <a:avLst/>
             </a:prstGeom>
-            <a:noFill/>
+            <a:grpFill/>
           </p:spPr>
           <p:txBody>
             <a:bodyPr wrap="none" rtlCol="0">
@@ -5471,7 +5252,7 @@
             <a:prstGeom prst="rect">
               <a:avLst/>
             </a:prstGeom>
-            <a:noFill/>
+            <a:grpFill/>
             <a:extLst>
               <a:ext uri="{909E8E84-426E-40DD-AFC4-6F175D3DCCD1}">
                 <a14:hiddenFill xmlns:a14="http://schemas.microsoft.com/office/drawing/2010/main">
@@ -5544,11 +5325,17 @@
         </p:nvGrpSpPr>
         <p:grpSpPr>
           <a:xfrm>
-            <a:off x="4517574" y="601937"/>
-            <a:ext cx="3603172" cy="5025978"/>
-            <a:chOff x="4517574" y="601937"/>
-            <a:chExt cx="3603172" cy="5025978"/>
+            <a:off x="4517574" y="696688"/>
+            <a:ext cx="3603172" cy="4931227"/>
+            <a:chOff x="4517574" y="696688"/>
+            <a:chExt cx="3603172" cy="4931227"/>
           </a:xfrm>
+          <a:solidFill>
+            <a:schemeClr val="tx2">
+              <a:lumMod val="50000"/>
+              <a:lumOff val="50000"/>
+            </a:schemeClr>
+          </a:solidFill>
         </p:grpSpPr>
         <p:sp>
           <p:nvSpPr>
@@ -5570,9 +5357,7 @@
             <a:prstGeom prst="rect">
               <a:avLst/>
             </a:prstGeom>
-            <a:solidFill>
-              <a:srgbClr val="FFC000"/>
-            </a:solidFill>
+            <a:grpFill/>
           </p:spPr>
           <p:style>
             <a:lnRef idx="2">
@@ -5668,43 +5453,6 @@
         </p:sp>
         <p:sp>
           <p:nvSpPr>
-            <p:cNvPr id="3" name="TextBox 2">
-              <a:extLst>
-                <a:ext uri="{FF2B5EF4-FFF2-40B4-BE49-F238E27FC236}">
-                  <a16:creationId xmlns:a16="http://schemas.microsoft.com/office/drawing/2014/main" id="{5518B1AF-4CBA-7CE5-46F6-6C42467F86A4}"/>
-                </a:ext>
-              </a:extLst>
-            </p:cNvPr>
-            <p:cNvSpPr txBox="1"/>
-            <p:nvPr/>
-          </p:nvSpPr>
-          <p:spPr>
-            <a:xfrm>
-              <a:off x="7294878" y="601937"/>
-              <a:ext cx="713657" cy="1015343"/>
-            </a:xfrm>
-            <a:prstGeom prst="rect">
-              <a:avLst/>
-            </a:prstGeom>
-            <a:noFill/>
-          </p:spPr>
-          <p:txBody>
-            <a:bodyPr wrap="none" rtlCol="0">
-              <a:spAutoFit/>
-            </a:bodyPr>
-            <a:lstStyle/>
-            <a:p>
-              <a:r>
-                <a:rPr lang="en-US" sz="5998" b="1" dirty="0">
-                  <a:latin typeface="Arial Rounded MT Bold" panose="020F0704030504030204" pitchFamily="34" charset="0"/>
-                </a:rPr>
-                <a:t>V</a:t>
-              </a:r>
-            </a:p>
-          </p:txBody>
-        </p:sp>
-        <p:sp>
-          <p:nvSpPr>
             <p:cNvPr id="9" name="TextBox 8">
               <a:extLst>
                 <a:ext uri="{FF2B5EF4-FFF2-40B4-BE49-F238E27FC236}">
@@ -5723,7 +5471,7 @@
             <a:prstGeom prst="rect">
               <a:avLst/>
             </a:prstGeom>
-            <a:noFill/>
+            <a:grpFill/>
           </p:spPr>
           <p:txBody>
             <a:bodyPr wrap="none" rtlCol="0">
@@ -5776,7 +5524,7 @@
             <a:prstGeom prst="rect">
               <a:avLst/>
             </a:prstGeom>
-            <a:noFill/>
+            <a:grpFill/>
             <a:extLst>
               <a:ext uri="{909E8E84-426E-40DD-AFC4-6F175D3DCCD1}">
                 <a14:hiddenFill xmlns:a14="http://schemas.microsoft.com/office/drawing/2010/main">
@@ -5835,274 +5583,220 @@
           <a:chExt cx="0" cy="0"/>
         </a:xfrm>
       </p:grpSpPr>
-      <p:grpSp>
-        <p:nvGrpSpPr>
-          <p:cNvPr id="4" name="Group 3">
-            <a:extLst>
-              <a:ext uri="{FF2B5EF4-FFF2-40B4-BE49-F238E27FC236}">
-                <a16:creationId xmlns:a16="http://schemas.microsoft.com/office/drawing/2014/main" id="{8B4BA484-F641-DAA3-35E8-3D2D569A976D}"/>
-              </a:ext>
-            </a:extLst>
-          </p:cNvPr>
-          <p:cNvGrpSpPr/>
+      <p:sp>
+        <p:nvSpPr>
+          <p:cNvPr id="2" name="Rectangle 1">
+            <a:extLst>
+              <a:ext uri="{FF2B5EF4-FFF2-40B4-BE49-F238E27FC236}">
+                <a16:creationId xmlns:a16="http://schemas.microsoft.com/office/drawing/2014/main" id="{4E3AB8C9-6ED3-4A4E-CB25-443CC2D52D3D}"/>
+              </a:ext>
+            </a:extLst>
+          </p:cNvPr>
+          <p:cNvSpPr/>
           <p:nvPr/>
-        </p:nvGrpSpPr>
-        <p:grpSpPr>
+        </p:nvSpPr>
+        <p:spPr>
           <a:xfrm>
-            <a:off x="4517574" y="601937"/>
-            <a:ext cx="3603172" cy="5025978"/>
-            <a:chOff x="4517574" y="601937"/>
-            <a:chExt cx="3603172" cy="5025978"/>
+            <a:off x="4517574" y="696688"/>
+            <a:ext cx="3603172" cy="4931227"/>
           </a:xfrm>
-        </p:grpSpPr>
-        <p:sp>
-          <p:nvSpPr>
-            <p:cNvPr id="2" name="Rectangle 1">
-              <a:extLst>
-                <a:ext uri="{FF2B5EF4-FFF2-40B4-BE49-F238E27FC236}">
-                  <a16:creationId xmlns:a16="http://schemas.microsoft.com/office/drawing/2014/main" id="{4E3AB8C9-6ED3-4A4E-CB25-443CC2D52D3D}"/>
-                </a:ext>
-              </a:extLst>
-            </p:cNvPr>
-            <p:cNvSpPr/>
-            <p:nvPr/>
-          </p:nvSpPr>
-          <p:spPr>
-            <a:xfrm>
-              <a:off x="4517574" y="696688"/>
-              <a:ext cx="3603172" cy="4931227"/>
-            </a:xfrm>
-            <a:prstGeom prst="rect">
+          <a:prstGeom prst="rect">
+            <a:avLst/>
+          </a:prstGeom>
+          <a:solidFill>
+            <a:schemeClr val="tx2">
+              <a:lumMod val="50000"/>
+              <a:lumOff val="50000"/>
+            </a:schemeClr>
+          </a:solidFill>
+        </p:spPr>
+        <p:style>
+          <a:lnRef idx="2">
+            <a:schemeClr val="accent1">
+              <a:shade val="15000"/>
+            </a:schemeClr>
+          </a:lnRef>
+          <a:fillRef idx="1">
+            <a:schemeClr val="accent1"/>
+          </a:fillRef>
+          <a:effectRef idx="0">
+            <a:schemeClr val="accent1"/>
+          </a:effectRef>
+          <a:fontRef idx="minor">
+            <a:schemeClr val="lt1"/>
+          </a:fontRef>
+        </p:style>
+        <p:txBody>
+          <a:bodyPr rot="0" spcFirstLastPara="0" vertOverflow="overflow" horzOverflow="overflow" vert="horz" wrap="square" lIns="91439" tIns="45721" rIns="91439" bIns="45721" numCol="1" spcCol="0" rtlCol="0" fromWordArt="0" anchor="ctr" anchorCtr="0" forceAA="0" compatLnSpc="1">
+            <a:prstTxWarp prst="textNoShape">
               <a:avLst/>
-            </a:prstGeom>
-            <a:solidFill>
-              <a:srgbClr val="FFC000"/>
-            </a:solidFill>
-          </p:spPr>
-          <p:style>
-            <a:lnRef idx="2">
-              <a:schemeClr val="accent1">
-                <a:shade val="15000"/>
-              </a:schemeClr>
-            </a:lnRef>
-            <a:fillRef idx="1">
-              <a:schemeClr val="accent1"/>
-            </a:fillRef>
-            <a:effectRef idx="0">
-              <a:schemeClr val="accent1"/>
-            </a:effectRef>
-            <a:fontRef idx="minor">
-              <a:schemeClr val="lt1"/>
-            </a:fontRef>
-          </p:style>
-          <p:txBody>
-            <a:bodyPr rot="0" spcFirstLastPara="0" vertOverflow="overflow" horzOverflow="overflow" vert="horz" wrap="square" lIns="91439" tIns="45721" rIns="91439" bIns="45721" numCol="1" spcCol="0" rtlCol="0" fromWordArt="0" anchor="ctr" anchorCtr="0" forceAA="0" compatLnSpc="1">
-              <a:prstTxWarp prst="textNoShape">
-                <a:avLst/>
-              </a:prstTxWarp>
-              <a:noAutofit/>
-            </a:bodyPr>
-            <a:lstStyle/>
-            <a:p>
-              <a:pPr algn="ctr"/>
-              <a:endParaRPr lang="en-US" sz="806" dirty="0"/>
-            </a:p>
-            <a:p>
-              <a:pPr algn="ctr"/>
-              <a:endParaRPr lang="en-US" sz="806" dirty="0"/>
-            </a:p>
-            <a:p>
-              <a:pPr algn="ctr"/>
-              <a:endParaRPr lang="en-US" sz="806" dirty="0"/>
-            </a:p>
-            <a:p>
-              <a:pPr algn="ctr"/>
-              <a:endParaRPr lang="en-US" sz="806" dirty="0"/>
-            </a:p>
-            <a:p>
-              <a:pPr algn="ctr"/>
-              <a:endParaRPr lang="en-US" sz="806" dirty="0"/>
-            </a:p>
-            <a:p>
-              <a:pPr algn="ctr"/>
-              <a:endParaRPr lang="en-US" sz="806" dirty="0"/>
-            </a:p>
-            <a:p>
-              <a:pPr algn="ctr"/>
-              <a:endParaRPr lang="en-US" sz="806" dirty="0"/>
-            </a:p>
-            <a:p>
-              <a:pPr algn="ctr"/>
-              <a:endParaRPr lang="en-US" sz="806" dirty="0"/>
-            </a:p>
-            <a:p>
-              <a:pPr algn="ctr"/>
-              <a:endParaRPr lang="en-US" sz="806" dirty="0"/>
-            </a:p>
-            <a:p>
-              <a:pPr algn="ctr"/>
-              <a:endParaRPr lang="en-US" sz="806" dirty="0"/>
-            </a:p>
-            <a:p>
-              <a:pPr algn="ctr"/>
-              <a:endParaRPr lang="en-US" sz="806" dirty="0"/>
-            </a:p>
-            <a:p>
-              <a:pPr algn="ctr"/>
-              <a:endParaRPr lang="en-US" sz="806" dirty="0"/>
-            </a:p>
-            <a:p>
-              <a:pPr algn="ctr"/>
-              <a:endParaRPr lang="en-US" sz="806" dirty="0"/>
-            </a:p>
-            <a:p>
-              <a:pPr algn="ctr"/>
-              <a:endParaRPr lang="en-US" sz="806" dirty="0"/>
-            </a:p>
-            <a:p>
-              <a:pPr algn="ctr"/>
-              <a:endParaRPr lang="en-US" sz="2799" b="1" dirty="0">
-                <a:solidFill>
-                  <a:schemeClr val="tx1"/>
-                </a:solidFill>
+            </a:prstTxWarp>
+            <a:noAutofit/>
+          </a:bodyPr>
+          <a:lstStyle/>
+          <a:p>
+            <a:pPr algn="ctr"/>
+            <a:endParaRPr lang="en-US" sz="806" dirty="0"/>
+          </a:p>
+          <a:p>
+            <a:pPr algn="ctr"/>
+            <a:endParaRPr lang="en-US" sz="806" dirty="0"/>
+          </a:p>
+          <a:p>
+            <a:pPr algn="ctr"/>
+            <a:endParaRPr lang="en-US" sz="806" dirty="0"/>
+          </a:p>
+          <a:p>
+            <a:pPr algn="ctr"/>
+            <a:endParaRPr lang="en-US" sz="806" dirty="0"/>
+          </a:p>
+          <a:p>
+            <a:pPr algn="ctr"/>
+            <a:endParaRPr lang="en-US" sz="806" dirty="0"/>
+          </a:p>
+          <a:p>
+            <a:pPr algn="ctr"/>
+            <a:endParaRPr lang="en-US" sz="806" dirty="0"/>
+          </a:p>
+          <a:p>
+            <a:pPr algn="ctr"/>
+            <a:endParaRPr lang="en-US" sz="806" dirty="0"/>
+          </a:p>
+          <a:p>
+            <a:pPr algn="ctr"/>
+            <a:endParaRPr lang="en-US" sz="806" dirty="0"/>
+          </a:p>
+          <a:p>
+            <a:pPr algn="ctr"/>
+            <a:endParaRPr lang="en-US" sz="806" dirty="0"/>
+          </a:p>
+          <a:p>
+            <a:pPr algn="ctr"/>
+            <a:endParaRPr lang="en-US" sz="806" dirty="0"/>
+          </a:p>
+          <a:p>
+            <a:pPr algn="ctr"/>
+            <a:endParaRPr lang="en-US" sz="806" dirty="0"/>
+          </a:p>
+          <a:p>
+            <a:pPr algn="ctr"/>
+            <a:endParaRPr lang="en-US" sz="806" dirty="0"/>
+          </a:p>
+          <a:p>
+            <a:pPr algn="ctr"/>
+            <a:endParaRPr lang="en-US" sz="806" dirty="0"/>
+          </a:p>
+          <a:p>
+            <a:pPr algn="ctr"/>
+            <a:endParaRPr lang="en-US" sz="806" dirty="0"/>
+          </a:p>
+          <a:p>
+            <a:pPr algn="ctr"/>
+            <a:endParaRPr lang="en-US" sz="2799" b="1" dirty="0">
+              <a:solidFill>
+                <a:schemeClr val="tx1"/>
+              </a:solidFill>
+              <a:latin typeface="Arial Rounded MT Bold" panose="020F0704030504030204" pitchFamily="34" charset="0"/>
+              <a:ea typeface="Segoe UI Symbol" panose="020B0502040204020203" pitchFamily="34" charset="0"/>
+            </a:endParaRPr>
+          </a:p>
+        </p:txBody>
+      </p:sp>
+      <p:sp>
+        <p:nvSpPr>
+          <p:cNvPr id="9" name="TextBox 8">
+            <a:extLst>
+              <a:ext uri="{FF2B5EF4-FFF2-40B4-BE49-F238E27FC236}">
+                <a16:creationId xmlns:a16="http://schemas.microsoft.com/office/drawing/2014/main" id="{3BB1AE95-815B-3245-CD20-4DCEBE82608F}"/>
+              </a:ext>
+            </a:extLst>
+          </p:cNvPr>
+          <p:cNvSpPr txBox="1"/>
+          <p:nvPr/>
+        </p:nvSpPr>
+        <p:spPr>
+          <a:xfrm>
+            <a:off x="4943895" y="4358865"/>
+            <a:ext cx="2871875" cy="1107996"/>
+          </a:xfrm>
+          <a:prstGeom prst="rect">
+            <a:avLst/>
+          </a:prstGeom>
+          <a:solidFill>
+            <a:schemeClr val="tx2">
+              <a:lumMod val="50000"/>
+              <a:lumOff val="50000"/>
+            </a:schemeClr>
+          </a:solidFill>
+        </p:spPr>
+        <p:txBody>
+          <a:bodyPr wrap="none" rtlCol="0">
+            <a:spAutoFit/>
+          </a:bodyPr>
+          <a:lstStyle/>
+          <a:p>
+            <a:pPr algn="ctr"/>
+            <a:r>
+              <a:rPr lang="en-US" sz="3300" dirty="0">
                 <a:latin typeface="Arial Rounded MT Bold" panose="020F0704030504030204" pitchFamily="34" charset="0"/>
-                <a:ea typeface="Segoe UI Symbol" panose="020B0502040204020203" pitchFamily="34" charset="0"/>
-              </a:endParaRPr>
-            </a:p>
-          </p:txBody>
-        </p:sp>
-        <p:sp>
-          <p:nvSpPr>
-            <p:cNvPr id="3" name="TextBox 2">
-              <a:extLst>
-                <a:ext uri="{FF2B5EF4-FFF2-40B4-BE49-F238E27FC236}">
-                  <a16:creationId xmlns:a16="http://schemas.microsoft.com/office/drawing/2014/main" id="{77C972F3-EAC1-54C9-22CF-CCF820951DE2}"/>
-                </a:ext>
-              </a:extLst>
-            </p:cNvPr>
-            <p:cNvSpPr txBox="1"/>
-            <p:nvPr/>
-          </p:nvSpPr>
-          <p:spPr>
-            <a:xfrm>
-              <a:off x="7294878" y="601937"/>
-              <a:ext cx="713657" cy="1015343"/>
-            </a:xfrm>
-            <a:prstGeom prst="rect">
-              <a:avLst/>
-            </a:prstGeom>
-            <a:noFill/>
-          </p:spPr>
-          <p:txBody>
-            <a:bodyPr wrap="none" rtlCol="0">
-              <a:spAutoFit/>
-            </a:bodyPr>
-            <a:lstStyle/>
-            <a:p>
-              <a:r>
-                <a:rPr lang="en-US" sz="5998" b="1" dirty="0">
-                  <a:latin typeface="Arial Rounded MT Bold" panose="020F0704030504030204" pitchFamily="34" charset="0"/>
-                </a:rPr>
-                <a:t>V</a:t>
-              </a:r>
-            </a:p>
-          </p:txBody>
-        </p:sp>
-        <p:sp>
-          <p:nvSpPr>
-            <p:cNvPr id="9" name="TextBox 8">
-              <a:extLst>
-                <a:ext uri="{FF2B5EF4-FFF2-40B4-BE49-F238E27FC236}">
-                  <a16:creationId xmlns:a16="http://schemas.microsoft.com/office/drawing/2014/main" id="{3BB1AE95-815B-3245-CD20-4DCEBE82608F}"/>
-                </a:ext>
-              </a:extLst>
-            </p:cNvPr>
-            <p:cNvSpPr txBox="1"/>
-            <p:nvPr/>
-          </p:nvSpPr>
-          <p:spPr>
-            <a:xfrm>
-              <a:off x="4943895" y="4358865"/>
-              <a:ext cx="2871875" cy="1107996"/>
-            </a:xfrm>
-            <a:prstGeom prst="rect">
-              <a:avLst/>
-            </a:prstGeom>
-            <a:noFill/>
-          </p:spPr>
-          <p:txBody>
-            <a:bodyPr wrap="none" rtlCol="0">
-              <a:spAutoFit/>
-            </a:bodyPr>
-            <a:lstStyle/>
-            <a:p>
-              <a:pPr algn="ctr"/>
-              <a:r>
-                <a:rPr lang="en-US" sz="3300" dirty="0">
-                  <a:latin typeface="Arial Rounded MT Bold" panose="020F0704030504030204" pitchFamily="34" charset="0"/>
-                </a:rPr>
-                <a:t>INPUT</a:t>
-              </a:r>
-            </a:p>
-            <a:p>
-              <a:pPr algn="ctr"/>
-              <a:r>
-                <a:rPr lang="en-US" sz="3300" dirty="0">
-                  <a:latin typeface="Arial Rounded MT Bold" panose="020F0704030504030204" pitchFamily="34" charset="0"/>
-                </a:rPr>
-                <a:t>VALIDATION</a:t>
-              </a:r>
-            </a:p>
-          </p:txBody>
-        </p:sp>
-        <p:pic>
-          <p:nvPicPr>
-            <p:cNvPr id="13314" name="Picture 2" descr="Validation Data Icons - Free SVG &amp; PNG Validation Data ...">
-              <a:extLst>
-                <a:ext uri="{FF2B5EF4-FFF2-40B4-BE49-F238E27FC236}">
-                  <a16:creationId xmlns:a16="http://schemas.microsoft.com/office/drawing/2014/main" id="{9003CEE7-46CE-1850-F4EA-AC50D82869C5}"/>
-                </a:ext>
-              </a:extLst>
-            </p:cNvPr>
-            <p:cNvPicPr>
-              <a:picLocks noChangeAspect="1" noChangeArrowheads="1"/>
-            </p:cNvPicPr>
-            <p:nvPr/>
-          </p:nvPicPr>
-          <p:blipFill>
-            <a:blip r:embed="rId2">
-              <a:extLst>
-                <a:ext uri="{28A0092B-C50C-407E-A947-70E740481C1C}">
-                  <a14:useLocalDpi xmlns:a14="http://schemas.microsoft.com/office/drawing/2010/main" val="0"/>
-                </a:ext>
-              </a:extLst>
-            </a:blip>
-            <a:srcRect/>
-            <a:stretch>
-              <a:fillRect/>
-            </a:stretch>
-          </p:blipFill>
-          <p:spPr bwMode="auto">
-            <a:xfrm>
-              <a:off x="4953715" y="1823357"/>
-              <a:ext cx="2389414" cy="2389414"/>
-            </a:xfrm>
-            <a:prstGeom prst="rect">
-              <a:avLst/>
-            </a:prstGeom>
-            <a:noFill/>
-            <a:extLst>
-              <a:ext uri="{909E8E84-426E-40DD-AFC4-6F175D3DCCD1}">
-                <a14:hiddenFill xmlns:a14="http://schemas.microsoft.com/office/drawing/2010/main">
-                  <a:solidFill>
-                    <a:srgbClr val="FFFFFF"/>
-                  </a:solidFill>
-                </a14:hiddenFill>
-              </a:ext>
-            </a:extLst>
-          </p:spPr>
-        </p:pic>
-      </p:grpSp>
+              </a:rPr>
+              <a:t>OUTPUT</a:t>
+            </a:r>
+          </a:p>
+          <a:p>
+            <a:pPr algn="ctr"/>
+            <a:r>
+              <a:rPr lang="en-US" sz="3300" dirty="0">
+                <a:latin typeface="Arial Rounded MT Bold" panose="020F0704030504030204" pitchFamily="34" charset="0"/>
+              </a:rPr>
+              <a:t>VALIDATION</a:t>
+            </a:r>
+          </a:p>
+        </p:txBody>
+      </p:sp>
+      <p:pic>
+        <p:nvPicPr>
+          <p:cNvPr id="13314" name="Picture 2" descr="Validation Data Icons - Free SVG &amp; PNG Validation Data ...">
+            <a:extLst>
+              <a:ext uri="{FF2B5EF4-FFF2-40B4-BE49-F238E27FC236}">
+                <a16:creationId xmlns:a16="http://schemas.microsoft.com/office/drawing/2014/main" id="{9003CEE7-46CE-1850-F4EA-AC50D82869C5}"/>
+              </a:ext>
+            </a:extLst>
+          </p:cNvPr>
+          <p:cNvPicPr>
+            <a:picLocks noChangeAspect="1" noChangeArrowheads="1"/>
+          </p:cNvPicPr>
+          <p:nvPr/>
+        </p:nvPicPr>
+        <p:blipFill>
+          <a:blip r:embed="rId2">
+            <a:extLst>
+              <a:ext uri="{28A0092B-C50C-407E-A947-70E740481C1C}">
+                <a14:useLocalDpi xmlns:a14="http://schemas.microsoft.com/office/drawing/2010/main" val="0"/>
+              </a:ext>
+            </a:extLst>
+          </a:blip>
+          <a:srcRect/>
+          <a:stretch>
+            <a:fillRect/>
+          </a:stretch>
+        </p:blipFill>
+        <p:spPr bwMode="auto">
+          <a:xfrm>
+            <a:off x="4953715" y="1823357"/>
+            <a:ext cx="2389414" cy="2389414"/>
+          </a:xfrm>
+          <a:prstGeom prst="rect">
+            <a:avLst/>
+          </a:prstGeom>
+          <a:solidFill>
+            <a:schemeClr val="tx2">
+              <a:lumMod val="50000"/>
+              <a:lumOff val="50000"/>
+            </a:schemeClr>
+          </a:solidFill>
+        </p:spPr>
+      </p:pic>
     </p:spTree>
     <p:extLst>
       <p:ext uri="{BB962C8B-B14F-4D97-AF65-F5344CB8AC3E}">
@@ -6734,43 +6428,6 @@
       </p:sp>
       <p:sp>
         <p:nvSpPr>
-          <p:cNvPr id="3" name="TextBox 2">
-            <a:extLst>
-              <a:ext uri="{FF2B5EF4-FFF2-40B4-BE49-F238E27FC236}">
-                <a16:creationId xmlns:a16="http://schemas.microsoft.com/office/drawing/2014/main" id="{A0BBB7CB-CCB8-FD0B-7A86-E083C967DA57}"/>
-              </a:ext>
-            </a:extLst>
-          </p:cNvPr>
-          <p:cNvSpPr txBox="1"/>
-          <p:nvPr/>
-        </p:nvSpPr>
-        <p:spPr>
-          <a:xfrm>
-            <a:off x="7294878" y="601937"/>
-            <a:ext cx="753732" cy="1015343"/>
-          </a:xfrm>
-          <a:prstGeom prst="rect">
-            <a:avLst/>
-          </a:prstGeom>
-          <a:noFill/>
-        </p:spPr>
-        <p:txBody>
-          <a:bodyPr wrap="none" rtlCol="0">
-            <a:spAutoFit/>
-          </a:bodyPr>
-          <a:lstStyle/>
-          <a:p>
-            <a:r>
-              <a:rPr lang="en-US" sz="5998" b="1" dirty="0">
-                <a:latin typeface="Arial Rounded MT Bold" panose="020F0704030504030204" pitchFamily="34" charset="0"/>
-              </a:rPr>
-              <a:t>C</a:t>
-            </a:r>
-          </a:p>
-        </p:txBody>
-      </p:sp>
-      <p:sp>
-        <p:nvSpPr>
           <p:cNvPr id="9" name="TextBox 8">
             <a:extLst>
               <a:ext uri="{FF2B5EF4-FFF2-40B4-BE49-F238E27FC236}">
@@ -6999,43 +6656,6 @@
               <a:latin typeface="Arial Rounded MT Bold" panose="020F0704030504030204" pitchFamily="34" charset="0"/>
               <a:ea typeface="Segoe UI Symbol" panose="020B0502040204020203" pitchFamily="34" charset="0"/>
             </a:endParaRPr>
-          </a:p>
-        </p:txBody>
-      </p:sp>
-      <p:sp>
-        <p:nvSpPr>
-          <p:cNvPr id="3" name="TextBox 2">
-            <a:extLst>
-              <a:ext uri="{FF2B5EF4-FFF2-40B4-BE49-F238E27FC236}">
-                <a16:creationId xmlns:a16="http://schemas.microsoft.com/office/drawing/2014/main" id="{9CBC3508-73E9-5E61-6B81-FD818B1A0E6E}"/>
-              </a:ext>
-            </a:extLst>
-          </p:cNvPr>
-          <p:cNvSpPr txBox="1"/>
-          <p:nvPr/>
-        </p:nvSpPr>
-        <p:spPr>
-          <a:xfrm>
-            <a:off x="7294878" y="601937"/>
-            <a:ext cx="753732" cy="1015343"/>
-          </a:xfrm>
-          <a:prstGeom prst="rect">
-            <a:avLst/>
-          </a:prstGeom>
-          <a:noFill/>
-        </p:spPr>
-        <p:txBody>
-          <a:bodyPr wrap="none" rtlCol="0">
-            <a:spAutoFit/>
-          </a:bodyPr>
-          <a:lstStyle/>
-          <a:p>
-            <a:r>
-              <a:rPr lang="en-US" sz="5998" b="1" dirty="0">
-                <a:latin typeface="Arial Rounded MT Bold" panose="020F0704030504030204" pitchFamily="34" charset="0"/>
-              </a:rPr>
-              <a:t>C</a:t>
-            </a:r>
           </a:p>
         </p:txBody>
       </p:sp>
@@ -7291,43 +6911,6 @@
       </p:sp>
       <p:sp>
         <p:nvSpPr>
-          <p:cNvPr id="3" name="TextBox 2">
-            <a:extLst>
-              <a:ext uri="{FF2B5EF4-FFF2-40B4-BE49-F238E27FC236}">
-                <a16:creationId xmlns:a16="http://schemas.microsoft.com/office/drawing/2014/main" id="{94C62715-C629-0F05-D33C-493872264D86}"/>
-              </a:ext>
-            </a:extLst>
-          </p:cNvPr>
-          <p:cNvSpPr txBox="1"/>
-          <p:nvPr/>
-        </p:nvSpPr>
-        <p:spPr>
-          <a:xfrm>
-            <a:off x="7294878" y="601937"/>
-            <a:ext cx="753732" cy="1015343"/>
-          </a:xfrm>
-          <a:prstGeom prst="rect">
-            <a:avLst/>
-          </a:prstGeom>
-          <a:noFill/>
-        </p:spPr>
-        <p:txBody>
-          <a:bodyPr wrap="none" rtlCol="0">
-            <a:spAutoFit/>
-          </a:bodyPr>
-          <a:lstStyle/>
-          <a:p>
-            <a:r>
-              <a:rPr lang="en-US" sz="5998" b="1" dirty="0">
-                <a:latin typeface="Arial Rounded MT Bold" panose="020F0704030504030204" pitchFamily="34" charset="0"/>
-              </a:rPr>
-              <a:t>C</a:t>
-            </a:r>
-          </a:p>
-        </p:txBody>
-      </p:sp>
-      <p:sp>
-        <p:nvSpPr>
           <p:cNvPr id="9" name="TextBox 8">
             <a:extLst>
               <a:ext uri="{FF2B5EF4-FFF2-40B4-BE49-F238E27FC236}">
@@ -7576,43 +7159,6 @@
       </p:sp>
       <p:sp>
         <p:nvSpPr>
-          <p:cNvPr id="3" name="TextBox 2">
-            <a:extLst>
-              <a:ext uri="{FF2B5EF4-FFF2-40B4-BE49-F238E27FC236}">
-                <a16:creationId xmlns:a16="http://schemas.microsoft.com/office/drawing/2014/main" id="{109B90C6-FC20-3195-2796-3D1499226FE8}"/>
-              </a:ext>
-            </a:extLst>
-          </p:cNvPr>
-          <p:cNvSpPr txBox="1"/>
-          <p:nvPr/>
-        </p:nvSpPr>
-        <p:spPr>
-          <a:xfrm>
-            <a:off x="7294878" y="601937"/>
-            <a:ext cx="753732" cy="1015343"/>
-          </a:xfrm>
-          <a:prstGeom prst="rect">
-            <a:avLst/>
-          </a:prstGeom>
-          <a:noFill/>
-        </p:spPr>
-        <p:txBody>
-          <a:bodyPr wrap="none" rtlCol="0">
-            <a:spAutoFit/>
-          </a:bodyPr>
-          <a:lstStyle/>
-          <a:p>
-            <a:r>
-              <a:rPr lang="en-US" sz="5998" b="1" dirty="0">
-                <a:latin typeface="Arial Rounded MT Bold" panose="020F0704030504030204" pitchFamily="34" charset="0"/>
-              </a:rPr>
-              <a:t>C</a:t>
-            </a:r>
-          </a:p>
-        </p:txBody>
-      </p:sp>
-      <p:sp>
-        <p:nvSpPr>
           <p:cNvPr id="9" name="TextBox 8">
             <a:extLst>
               <a:ext uri="{FF2B5EF4-FFF2-40B4-BE49-F238E27FC236}">
@@ -7847,43 +7393,6 @@
               <a:latin typeface="Arial Rounded MT Bold" panose="020F0704030504030204" pitchFamily="34" charset="0"/>
               <a:ea typeface="Segoe UI Symbol" panose="020B0502040204020203" pitchFamily="34" charset="0"/>
             </a:endParaRPr>
-          </a:p>
-        </p:txBody>
-      </p:sp>
-      <p:sp>
-        <p:nvSpPr>
-          <p:cNvPr id="3" name="TextBox 2">
-            <a:extLst>
-              <a:ext uri="{FF2B5EF4-FFF2-40B4-BE49-F238E27FC236}">
-                <a16:creationId xmlns:a16="http://schemas.microsoft.com/office/drawing/2014/main" id="{3013AC7A-56CC-8143-515D-D331BE27B9F8}"/>
-              </a:ext>
-            </a:extLst>
-          </p:cNvPr>
-          <p:cNvSpPr txBox="1"/>
-          <p:nvPr/>
-        </p:nvSpPr>
-        <p:spPr>
-          <a:xfrm>
-            <a:off x="7294878" y="601937"/>
-            <a:ext cx="753732" cy="1015343"/>
-          </a:xfrm>
-          <a:prstGeom prst="rect">
-            <a:avLst/>
-          </a:prstGeom>
-          <a:noFill/>
-        </p:spPr>
-        <p:txBody>
-          <a:bodyPr wrap="none" rtlCol="0">
-            <a:spAutoFit/>
-          </a:bodyPr>
-          <a:lstStyle/>
-          <a:p>
-            <a:r>
-              <a:rPr lang="en-US" sz="5998" b="1" dirty="0">
-                <a:latin typeface="Arial Rounded MT Bold" panose="020F0704030504030204" pitchFamily="34" charset="0"/>
-              </a:rPr>
-              <a:t>C</a:t>
-            </a:r>
           </a:p>
         </p:txBody>
       </p:sp>
@@ -8134,43 +7643,6 @@
               <a:latin typeface="Arial Rounded MT Bold" panose="020F0704030504030204" pitchFamily="34" charset="0"/>
               <a:ea typeface="Segoe UI Symbol" panose="020B0502040204020203" pitchFamily="34" charset="0"/>
             </a:endParaRPr>
-          </a:p>
-        </p:txBody>
-      </p:sp>
-      <p:sp>
-        <p:nvSpPr>
-          <p:cNvPr id="3" name="TextBox 2">
-            <a:extLst>
-              <a:ext uri="{FF2B5EF4-FFF2-40B4-BE49-F238E27FC236}">
-                <a16:creationId xmlns:a16="http://schemas.microsoft.com/office/drawing/2014/main" id="{B3C5B922-BB85-DF6B-C7C2-BDA9E59A3E68}"/>
-              </a:ext>
-            </a:extLst>
-          </p:cNvPr>
-          <p:cNvSpPr txBox="1"/>
-          <p:nvPr/>
-        </p:nvSpPr>
-        <p:spPr>
-          <a:xfrm>
-            <a:off x="7294878" y="601937"/>
-            <a:ext cx="753732" cy="1015343"/>
-          </a:xfrm>
-          <a:prstGeom prst="rect">
-            <a:avLst/>
-          </a:prstGeom>
-          <a:noFill/>
-        </p:spPr>
-        <p:txBody>
-          <a:bodyPr wrap="none" rtlCol="0">
-            <a:spAutoFit/>
-          </a:bodyPr>
-          <a:lstStyle/>
-          <a:p>
-            <a:r>
-              <a:rPr lang="en-US" sz="5998" b="1" dirty="0">
-                <a:latin typeface="Arial Rounded MT Bold" panose="020F0704030504030204" pitchFamily="34" charset="0"/>
-              </a:rPr>
-              <a:t>C</a:t>
-            </a:r>
           </a:p>
         </p:txBody>
       </p:sp>
@@ -8465,7 +7937,7 @@
         </p:nvSpPr>
         <p:spPr>
           <a:xfrm>
-            <a:off x="7294878" y="601937"/>
+            <a:off x="7294878" y="612823"/>
             <a:ext cx="753732" cy="1015343"/>
           </a:xfrm>
           <a:prstGeom prst="rect">
@@ -8779,7 +8251,7 @@
         </p:nvSpPr>
         <p:spPr>
           <a:xfrm>
-            <a:off x="7294878" y="601937"/>
+            <a:off x="7294878" y="612823"/>
             <a:ext cx="753732" cy="1015343"/>
           </a:xfrm>
           <a:prstGeom prst="rect">
@@ -10465,6 +9937,466 @@
     <p:extLst>
       <p:ext uri="{BB962C8B-B14F-4D97-AF65-F5344CB8AC3E}">
         <p14:creationId xmlns:p14="http://schemas.microsoft.com/office/powerpoint/2010/main" val="1648329558"/>
+      </p:ext>
+    </p:extLst>
+  </p:cSld>
+  <p:clrMapOvr>
+    <a:masterClrMapping/>
+  </p:clrMapOvr>
+</p:sld>
+</file>
+
+<file path=ppt/slides/slide35.xml><?xml version="1.0" encoding="utf-8"?>
+<p:sld xmlns:a="http://schemas.openxmlformats.org/drawingml/2006/main" xmlns:r="http://schemas.openxmlformats.org/officeDocument/2006/relationships" xmlns:p="http://schemas.openxmlformats.org/presentationml/2006/main">
+  <p:cSld>
+    <p:bg>
+      <p:bgPr>
+        <a:solidFill>
+          <a:schemeClr val="bg1">
+            <a:alpha val="11000"/>
+          </a:schemeClr>
+        </a:solidFill>
+        <a:effectLst/>
+      </p:bgPr>
+    </p:bg>
+    <p:spTree>
+      <p:nvGrpSpPr>
+        <p:cNvPr id="1" name="">
+          <a:extLst>
+            <a:ext uri="{FF2B5EF4-FFF2-40B4-BE49-F238E27FC236}">
+              <a16:creationId xmlns:a16="http://schemas.microsoft.com/office/drawing/2014/main" id="{0E37AB3A-7464-0CDE-45B8-1FFEF39B0575}"/>
+            </a:ext>
+          </a:extLst>
+        </p:cNvPr>
+        <p:cNvGrpSpPr/>
+        <p:nvPr/>
+      </p:nvGrpSpPr>
+      <p:grpSpPr>
+        <a:xfrm>
+          <a:off x="0" y="0"/>
+          <a:ext cx="0" cy="0"/>
+          <a:chOff x="0" y="0"/>
+          <a:chExt cx="0" cy="0"/>
+        </a:xfrm>
+      </p:grpSpPr>
+      <p:sp>
+        <p:nvSpPr>
+          <p:cNvPr id="2" name="Rectangle 1">
+            <a:extLst>
+              <a:ext uri="{FF2B5EF4-FFF2-40B4-BE49-F238E27FC236}">
+                <a16:creationId xmlns:a16="http://schemas.microsoft.com/office/drawing/2014/main" id="{471FC972-EB75-D54A-7227-3CA9A2F22685}"/>
+              </a:ext>
+            </a:extLst>
+          </p:cNvPr>
+          <p:cNvSpPr/>
+          <p:nvPr/>
+        </p:nvSpPr>
+        <p:spPr>
+          <a:xfrm>
+            <a:off x="4517574" y="696688"/>
+            <a:ext cx="3603172" cy="4931227"/>
+          </a:xfrm>
+          <a:prstGeom prst="rect">
+            <a:avLst/>
+          </a:prstGeom>
+          <a:solidFill>
+            <a:srgbClr val="FF0000"/>
+          </a:solidFill>
+        </p:spPr>
+        <p:style>
+          <a:lnRef idx="2">
+            <a:schemeClr val="accent1">
+              <a:shade val="15000"/>
+            </a:schemeClr>
+          </a:lnRef>
+          <a:fillRef idx="1">
+            <a:schemeClr val="accent1"/>
+          </a:fillRef>
+          <a:effectRef idx="0">
+            <a:schemeClr val="accent1"/>
+          </a:effectRef>
+          <a:fontRef idx="minor">
+            <a:schemeClr val="lt1"/>
+          </a:fontRef>
+        </p:style>
+        <p:txBody>
+          <a:bodyPr rot="0" spcFirstLastPara="0" vertOverflow="overflow" horzOverflow="overflow" vert="horz" wrap="square" lIns="91439" tIns="45721" rIns="91439" bIns="45721" numCol="1" spcCol="0" rtlCol="0" fromWordArt="0" anchor="ctr" anchorCtr="0" forceAA="0" compatLnSpc="1">
+            <a:prstTxWarp prst="textNoShape">
+              <a:avLst/>
+            </a:prstTxWarp>
+            <a:noAutofit/>
+          </a:bodyPr>
+          <a:lstStyle/>
+          <a:p>
+            <a:pPr algn="ctr"/>
+            <a:endParaRPr lang="en-US" sz="806" dirty="0"/>
+          </a:p>
+          <a:p>
+            <a:pPr algn="ctr"/>
+            <a:endParaRPr lang="en-US" sz="806" dirty="0"/>
+          </a:p>
+          <a:p>
+            <a:pPr algn="ctr"/>
+            <a:endParaRPr lang="en-US" sz="806" dirty="0"/>
+          </a:p>
+          <a:p>
+            <a:pPr algn="ctr"/>
+            <a:endParaRPr lang="en-US" sz="806" dirty="0"/>
+          </a:p>
+          <a:p>
+            <a:pPr algn="ctr"/>
+            <a:endParaRPr lang="en-US" sz="806" dirty="0"/>
+          </a:p>
+          <a:p>
+            <a:pPr algn="ctr"/>
+            <a:endParaRPr lang="en-US" sz="806" dirty="0"/>
+          </a:p>
+          <a:p>
+            <a:pPr algn="ctr"/>
+            <a:endParaRPr lang="en-US" sz="806" dirty="0"/>
+          </a:p>
+          <a:p>
+            <a:pPr algn="ctr"/>
+            <a:endParaRPr lang="en-US" sz="806" dirty="0"/>
+          </a:p>
+          <a:p>
+            <a:pPr algn="ctr"/>
+            <a:endParaRPr lang="en-US" sz="806" dirty="0"/>
+          </a:p>
+          <a:p>
+            <a:pPr algn="ctr"/>
+            <a:endParaRPr lang="en-US" sz="806" dirty="0"/>
+          </a:p>
+          <a:p>
+            <a:pPr algn="ctr"/>
+            <a:endParaRPr lang="en-US" sz="806" dirty="0"/>
+          </a:p>
+          <a:p>
+            <a:pPr algn="ctr"/>
+            <a:endParaRPr lang="en-US" sz="806" dirty="0"/>
+          </a:p>
+          <a:p>
+            <a:pPr algn="ctr"/>
+            <a:endParaRPr lang="en-US" sz="806" dirty="0"/>
+          </a:p>
+          <a:p>
+            <a:pPr algn="ctr"/>
+            <a:endParaRPr lang="en-US" sz="806" dirty="0"/>
+          </a:p>
+          <a:p>
+            <a:pPr algn="ctr"/>
+            <a:endParaRPr lang="en-US" sz="2799" b="1" dirty="0">
+              <a:solidFill>
+                <a:schemeClr val="tx1"/>
+              </a:solidFill>
+              <a:latin typeface="Arial Rounded MT Bold" panose="020F0704030504030204" pitchFamily="34" charset="0"/>
+              <a:ea typeface="Segoe UI Symbol" panose="020B0502040204020203" pitchFamily="34" charset="0"/>
+            </a:endParaRPr>
+          </a:p>
+        </p:txBody>
+      </p:sp>
+      <p:sp>
+        <p:nvSpPr>
+          <p:cNvPr id="9" name="TextBox 8">
+            <a:extLst>
+              <a:ext uri="{FF2B5EF4-FFF2-40B4-BE49-F238E27FC236}">
+                <a16:creationId xmlns:a16="http://schemas.microsoft.com/office/drawing/2014/main" id="{77DF0C61-2321-1DAF-108B-3E6C1E9892AB}"/>
+              </a:ext>
+            </a:extLst>
+          </p:cNvPr>
+          <p:cNvSpPr txBox="1"/>
+          <p:nvPr/>
+        </p:nvSpPr>
+        <p:spPr>
+          <a:xfrm>
+            <a:off x="5836263" y="4548370"/>
+            <a:ext cx="1043620" cy="553998"/>
+          </a:xfrm>
+          <a:prstGeom prst="rect">
+            <a:avLst/>
+          </a:prstGeom>
+          <a:noFill/>
+        </p:spPr>
+        <p:txBody>
+          <a:bodyPr wrap="none" rtlCol="0">
+            <a:spAutoFit/>
+          </a:bodyPr>
+          <a:lstStyle/>
+          <a:p>
+            <a:pPr algn="ctr"/>
+            <a:r>
+              <a:rPr lang="en-US" sz="3000" dirty="0">
+                <a:latin typeface="Arial Rounded MT Bold" panose="020F0704030504030204" pitchFamily="34" charset="0"/>
+              </a:rPr>
+              <a:t>BUG</a:t>
+            </a:r>
+          </a:p>
+        </p:txBody>
+      </p:sp>
+      <p:pic>
+        <p:nvPicPr>
+          <p:cNvPr id="5" name="Picture 4">
+            <a:extLst>
+              <a:ext uri="{FF2B5EF4-FFF2-40B4-BE49-F238E27FC236}">
+                <a16:creationId xmlns:a16="http://schemas.microsoft.com/office/drawing/2014/main" id="{6C7FDEF8-88B7-FCBE-7AD2-8A8D254F2362}"/>
+              </a:ext>
+            </a:extLst>
+          </p:cNvPr>
+          <p:cNvPicPr>
+            <a:picLocks noChangeAspect="1"/>
+          </p:cNvPicPr>
+          <p:nvPr/>
+        </p:nvPicPr>
+        <p:blipFill>
+          <a:blip r:embed="rId2"/>
+          <a:stretch>
+            <a:fillRect/>
+          </a:stretch>
+        </p:blipFill>
+        <p:spPr>
+          <a:xfrm>
+            <a:off x="5421081" y="2008735"/>
+            <a:ext cx="1808395" cy="2522884"/>
+          </a:xfrm>
+          <a:prstGeom prst="rect">
+            <a:avLst/>
+          </a:prstGeom>
+        </p:spPr>
+      </p:pic>
+    </p:spTree>
+    <p:extLst>
+      <p:ext uri="{BB962C8B-B14F-4D97-AF65-F5344CB8AC3E}">
+        <p14:creationId xmlns:p14="http://schemas.microsoft.com/office/powerpoint/2010/main" val="1943831940"/>
+      </p:ext>
+    </p:extLst>
+  </p:cSld>
+  <p:clrMapOvr>
+    <a:masterClrMapping/>
+  </p:clrMapOvr>
+</p:sld>
+</file>
+
+<file path=ppt/slides/slide36.xml><?xml version="1.0" encoding="utf-8"?>
+<p:sld xmlns:a="http://schemas.openxmlformats.org/drawingml/2006/main" xmlns:r="http://schemas.openxmlformats.org/officeDocument/2006/relationships" xmlns:p="http://schemas.openxmlformats.org/presentationml/2006/main">
+  <p:cSld>
+    <p:bg>
+      <p:bgPr>
+        <a:solidFill>
+          <a:schemeClr val="bg1">
+            <a:alpha val="11000"/>
+          </a:schemeClr>
+        </a:solidFill>
+        <a:effectLst/>
+      </p:bgPr>
+    </p:bg>
+    <p:spTree>
+      <p:nvGrpSpPr>
+        <p:cNvPr id="1" name="">
+          <a:extLst>
+            <a:ext uri="{FF2B5EF4-FFF2-40B4-BE49-F238E27FC236}">
+              <a16:creationId xmlns:a16="http://schemas.microsoft.com/office/drawing/2014/main" id="{A43C59CB-B216-D0CB-8A62-852A72E9629E}"/>
+            </a:ext>
+          </a:extLst>
+        </p:cNvPr>
+        <p:cNvGrpSpPr/>
+        <p:nvPr/>
+      </p:nvGrpSpPr>
+      <p:grpSpPr>
+        <a:xfrm>
+          <a:off x="0" y="0"/>
+          <a:ext cx="0" cy="0"/>
+          <a:chOff x="0" y="0"/>
+          <a:chExt cx="0" cy="0"/>
+        </a:xfrm>
+      </p:grpSpPr>
+      <p:sp>
+        <p:nvSpPr>
+          <p:cNvPr id="2" name="Rectangle 1">
+            <a:extLst>
+              <a:ext uri="{FF2B5EF4-FFF2-40B4-BE49-F238E27FC236}">
+                <a16:creationId xmlns:a16="http://schemas.microsoft.com/office/drawing/2014/main" id="{1754E976-2309-7A0F-5A33-36E40824A2FD}"/>
+              </a:ext>
+            </a:extLst>
+          </p:cNvPr>
+          <p:cNvSpPr/>
+          <p:nvPr/>
+        </p:nvSpPr>
+        <p:spPr>
+          <a:xfrm>
+            <a:off x="4517574" y="696688"/>
+            <a:ext cx="3603172" cy="4931227"/>
+          </a:xfrm>
+          <a:prstGeom prst="rect">
+            <a:avLst/>
+          </a:prstGeom>
+          <a:solidFill>
+            <a:srgbClr val="FF0000"/>
+          </a:solidFill>
+        </p:spPr>
+        <p:style>
+          <a:lnRef idx="2">
+            <a:schemeClr val="accent1">
+              <a:shade val="15000"/>
+            </a:schemeClr>
+          </a:lnRef>
+          <a:fillRef idx="1">
+            <a:schemeClr val="accent1"/>
+          </a:fillRef>
+          <a:effectRef idx="0">
+            <a:schemeClr val="accent1"/>
+          </a:effectRef>
+          <a:fontRef idx="minor">
+            <a:schemeClr val="lt1"/>
+          </a:fontRef>
+        </p:style>
+        <p:txBody>
+          <a:bodyPr rot="0" spcFirstLastPara="0" vertOverflow="overflow" horzOverflow="overflow" vert="horz" wrap="square" lIns="91439" tIns="45721" rIns="91439" bIns="45721" numCol="1" spcCol="0" rtlCol="0" fromWordArt="0" anchor="ctr" anchorCtr="0" forceAA="0" compatLnSpc="1">
+            <a:prstTxWarp prst="textNoShape">
+              <a:avLst/>
+            </a:prstTxWarp>
+            <a:noAutofit/>
+          </a:bodyPr>
+          <a:lstStyle/>
+          <a:p>
+            <a:pPr algn="ctr"/>
+            <a:endParaRPr lang="en-US" sz="806" dirty="0"/>
+          </a:p>
+          <a:p>
+            <a:pPr algn="ctr"/>
+            <a:endParaRPr lang="en-US" sz="806" dirty="0"/>
+          </a:p>
+          <a:p>
+            <a:pPr algn="ctr"/>
+            <a:endParaRPr lang="en-US" sz="806" dirty="0"/>
+          </a:p>
+          <a:p>
+            <a:pPr algn="ctr"/>
+            <a:endParaRPr lang="en-US" sz="806" dirty="0"/>
+          </a:p>
+          <a:p>
+            <a:pPr algn="ctr"/>
+            <a:endParaRPr lang="en-US" sz="806" dirty="0"/>
+          </a:p>
+          <a:p>
+            <a:pPr algn="ctr"/>
+            <a:endParaRPr lang="en-US" sz="806" dirty="0"/>
+          </a:p>
+          <a:p>
+            <a:pPr algn="ctr"/>
+            <a:endParaRPr lang="en-US" sz="806" dirty="0"/>
+          </a:p>
+          <a:p>
+            <a:pPr algn="ctr"/>
+            <a:endParaRPr lang="en-US" sz="806" dirty="0"/>
+          </a:p>
+          <a:p>
+            <a:pPr algn="ctr"/>
+            <a:endParaRPr lang="en-US" sz="806" dirty="0"/>
+          </a:p>
+          <a:p>
+            <a:pPr algn="ctr"/>
+            <a:endParaRPr lang="en-US" sz="806" dirty="0"/>
+          </a:p>
+          <a:p>
+            <a:pPr algn="ctr"/>
+            <a:endParaRPr lang="en-US" sz="806" dirty="0"/>
+          </a:p>
+          <a:p>
+            <a:pPr algn="ctr"/>
+            <a:endParaRPr lang="en-US" sz="806" dirty="0"/>
+          </a:p>
+          <a:p>
+            <a:pPr algn="ctr"/>
+            <a:endParaRPr lang="en-US" sz="806" dirty="0"/>
+          </a:p>
+          <a:p>
+            <a:pPr algn="ctr"/>
+            <a:endParaRPr lang="en-US" sz="806" dirty="0"/>
+          </a:p>
+          <a:p>
+            <a:pPr algn="ctr"/>
+            <a:endParaRPr lang="en-US" sz="2799" b="1" dirty="0">
+              <a:solidFill>
+                <a:schemeClr val="tx1"/>
+              </a:solidFill>
+              <a:latin typeface="Arial Rounded MT Bold" panose="020F0704030504030204" pitchFamily="34" charset="0"/>
+              <a:ea typeface="Segoe UI Symbol" panose="020B0502040204020203" pitchFamily="34" charset="0"/>
+            </a:endParaRPr>
+          </a:p>
+        </p:txBody>
+      </p:sp>
+      <p:sp>
+        <p:nvSpPr>
+          <p:cNvPr id="9" name="TextBox 8">
+            <a:extLst>
+              <a:ext uri="{FF2B5EF4-FFF2-40B4-BE49-F238E27FC236}">
+                <a16:creationId xmlns:a16="http://schemas.microsoft.com/office/drawing/2014/main" id="{E5762F18-3129-C112-424E-8CD18B8D5B0E}"/>
+              </a:ext>
+            </a:extLst>
+          </p:cNvPr>
+          <p:cNvSpPr txBox="1"/>
+          <p:nvPr/>
+        </p:nvSpPr>
+        <p:spPr>
+          <a:xfrm>
+            <a:off x="5237152" y="4548370"/>
+            <a:ext cx="2154757" cy="553998"/>
+          </a:xfrm>
+          <a:prstGeom prst="rect">
+            <a:avLst/>
+          </a:prstGeom>
+          <a:noFill/>
+        </p:spPr>
+        <p:txBody>
+          <a:bodyPr wrap="none" rtlCol="0">
+            <a:spAutoFit/>
+          </a:bodyPr>
+          <a:lstStyle/>
+          <a:p>
+            <a:pPr algn="ctr"/>
+            <a:r>
+              <a:rPr lang="en-US" sz="3000" dirty="0">
+                <a:latin typeface="Arial Rounded MT Bold" panose="020F0704030504030204" pitchFamily="34" charset="0"/>
+              </a:rPr>
+              <a:t>DISASTER</a:t>
+            </a:r>
+          </a:p>
+        </p:txBody>
+      </p:sp>
+      <p:pic>
+        <p:nvPicPr>
+          <p:cNvPr id="5" name="Picture 4" descr="Computer Desktop Repair Icon in SVG, PNG formats">
+            <a:extLst>
+              <a:ext uri="{FF2B5EF4-FFF2-40B4-BE49-F238E27FC236}">
+                <a16:creationId xmlns:a16="http://schemas.microsoft.com/office/drawing/2014/main" id="{4733C32E-A806-9843-951F-FD404A620B04}"/>
+              </a:ext>
+            </a:extLst>
+          </p:cNvPr>
+          <p:cNvPicPr>
+            <a:picLocks noChangeAspect="1"/>
+          </p:cNvPicPr>
+          <p:nvPr/>
+        </p:nvPicPr>
+        <p:blipFill>
+          <a:blip r:embed="rId2"/>
+          <a:stretch>
+            <a:fillRect/>
+          </a:stretch>
+        </p:blipFill>
+        <p:spPr>
+          <a:xfrm>
+            <a:off x="5285914" y="1969386"/>
+            <a:ext cx="2385830" cy="2385830"/>
+          </a:xfrm>
+          <a:prstGeom prst="rect">
+            <a:avLst/>
+          </a:prstGeom>
+        </p:spPr>
+      </p:pic>
+    </p:spTree>
+    <p:extLst>
+      <p:ext uri="{BB962C8B-B14F-4D97-AF65-F5344CB8AC3E}">
+        <p14:creationId xmlns:p14="http://schemas.microsoft.com/office/powerpoint/2010/main" val="2030690285"/>
       </p:ext>
     </p:extLst>
   </p:cSld>
@@ -11412,11 +11344,17 @@
         </p:nvGrpSpPr>
         <p:grpSpPr>
           <a:xfrm>
-            <a:off x="4517574" y="601937"/>
-            <a:ext cx="3603172" cy="5025978"/>
-            <a:chOff x="4517574" y="601937"/>
-            <a:chExt cx="3603172" cy="5025978"/>
+            <a:off x="4517574" y="696688"/>
+            <a:ext cx="3603172" cy="4931227"/>
+            <a:chOff x="4517574" y="696688"/>
+            <a:chExt cx="3603172" cy="4931227"/>
           </a:xfrm>
+          <a:solidFill>
+            <a:schemeClr val="tx2">
+              <a:lumMod val="50000"/>
+              <a:lumOff val="50000"/>
+            </a:schemeClr>
+          </a:solidFill>
         </p:grpSpPr>
         <p:sp>
           <p:nvSpPr>
@@ -11438,12 +11376,7 @@
             <a:prstGeom prst="rect">
               <a:avLst/>
             </a:prstGeom>
-            <a:solidFill>
-              <a:schemeClr val="accent5">
-                <a:lumMod val="60000"/>
-                <a:lumOff val="40000"/>
-              </a:schemeClr>
-            </a:solidFill>
+            <a:grpFill/>
           </p:spPr>
           <p:style>
             <a:lnRef idx="2">
@@ -11539,43 +11472,6 @@
         </p:sp>
         <p:sp>
           <p:nvSpPr>
-            <p:cNvPr id="3" name="TextBox 2">
-              <a:extLst>
-                <a:ext uri="{FF2B5EF4-FFF2-40B4-BE49-F238E27FC236}">
-                  <a16:creationId xmlns:a16="http://schemas.microsoft.com/office/drawing/2014/main" id="{7BF53771-069C-5157-89BD-E1E2DADE5B79}"/>
-                </a:ext>
-              </a:extLst>
-            </p:cNvPr>
-            <p:cNvSpPr txBox="1"/>
-            <p:nvPr/>
-          </p:nvSpPr>
-          <p:spPr>
-            <a:xfrm>
-              <a:off x="7294878" y="601937"/>
-              <a:ext cx="825867" cy="1015343"/>
-            </a:xfrm>
-            <a:prstGeom prst="rect">
-              <a:avLst/>
-            </a:prstGeom>
-            <a:noFill/>
-          </p:spPr>
-          <p:txBody>
-            <a:bodyPr wrap="none" rtlCol="0">
-              <a:spAutoFit/>
-            </a:bodyPr>
-            <a:lstStyle/>
-            <a:p>
-              <a:r>
-                <a:rPr lang="en-US" sz="5998" b="1" dirty="0">
-                  <a:latin typeface="Arial Rounded MT Bold" panose="020F0704030504030204" pitchFamily="34" charset="0"/>
-                </a:rPr>
-                <a:t>M</a:t>
-              </a:r>
-            </a:p>
-          </p:txBody>
-        </p:sp>
-        <p:sp>
-          <p:nvSpPr>
             <p:cNvPr id="9" name="TextBox 8">
               <a:extLst>
                 <a:ext uri="{FF2B5EF4-FFF2-40B4-BE49-F238E27FC236}">
@@ -11594,7 +11490,7 @@
             <a:prstGeom prst="rect">
               <a:avLst/>
             </a:prstGeom>
-            <a:noFill/>
+            <a:grpFill/>
           </p:spPr>
           <p:txBody>
             <a:bodyPr wrap="none" rtlCol="0">
@@ -11647,7 +11543,7 @@
             <a:prstGeom prst="rect">
               <a:avLst/>
             </a:prstGeom>
-            <a:noFill/>
+            <a:grpFill/>
             <a:extLst>
               <a:ext uri="{909E8E84-426E-40DD-AFC4-6F175D3DCCD1}">
                 <a14:hiddenFill xmlns:a14="http://schemas.microsoft.com/office/drawing/2010/main">
@@ -11720,11 +11616,17 @@
         </p:nvGrpSpPr>
         <p:grpSpPr>
           <a:xfrm>
-            <a:off x="4517574" y="601937"/>
-            <a:ext cx="3603172" cy="5025978"/>
-            <a:chOff x="4517574" y="601937"/>
-            <a:chExt cx="3603172" cy="5025978"/>
+            <a:off x="4517574" y="696688"/>
+            <a:ext cx="3603172" cy="4931227"/>
+            <a:chOff x="4517574" y="696688"/>
+            <a:chExt cx="3603172" cy="4931227"/>
           </a:xfrm>
+          <a:solidFill>
+            <a:schemeClr val="tx2">
+              <a:lumMod val="50000"/>
+              <a:lumOff val="50000"/>
+            </a:schemeClr>
+          </a:solidFill>
         </p:grpSpPr>
         <p:sp>
           <p:nvSpPr>
@@ -11746,12 +11648,7 @@
             <a:prstGeom prst="rect">
               <a:avLst/>
             </a:prstGeom>
-            <a:solidFill>
-              <a:schemeClr val="accent5">
-                <a:lumMod val="60000"/>
-                <a:lumOff val="40000"/>
-              </a:schemeClr>
-            </a:solidFill>
+            <a:grpFill/>
           </p:spPr>
           <p:style>
             <a:lnRef idx="2">
@@ -11847,43 +11744,6 @@
         </p:sp>
         <p:sp>
           <p:nvSpPr>
-            <p:cNvPr id="3" name="TextBox 2">
-              <a:extLst>
-                <a:ext uri="{FF2B5EF4-FFF2-40B4-BE49-F238E27FC236}">
-                  <a16:creationId xmlns:a16="http://schemas.microsoft.com/office/drawing/2014/main" id="{D80BDA8E-840F-8DAB-B4BC-7066356833A6}"/>
-                </a:ext>
-              </a:extLst>
-            </p:cNvPr>
-            <p:cNvSpPr txBox="1"/>
-            <p:nvPr/>
-          </p:nvSpPr>
-          <p:spPr>
-            <a:xfrm>
-              <a:off x="7294878" y="601937"/>
-              <a:ext cx="825867" cy="1015343"/>
-            </a:xfrm>
-            <a:prstGeom prst="rect">
-              <a:avLst/>
-            </a:prstGeom>
-            <a:noFill/>
-          </p:spPr>
-          <p:txBody>
-            <a:bodyPr wrap="none" rtlCol="0">
-              <a:spAutoFit/>
-            </a:bodyPr>
-            <a:lstStyle/>
-            <a:p>
-              <a:r>
-                <a:rPr lang="en-US" sz="5998" b="1" dirty="0">
-                  <a:latin typeface="Arial Rounded MT Bold" panose="020F0704030504030204" pitchFamily="34" charset="0"/>
-                </a:rPr>
-                <a:t>M</a:t>
-              </a:r>
-            </a:p>
-          </p:txBody>
-        </p:sp>
-        <p:sp>
-          <p:nvSpPr>
             <p:cNvPr id="9" name="TextBox 8">
               <a:extLst>
                 <a:ext uri="{FF2B5EF4-FFF2-40B4-BE49-F238E27FC236}">
@@ -11902,7 +11762,7 @@
             <a:prstGeom prst="rect">
               <a:avLst/>
             </a:prstGeom>
-            <a:noFill/>
+            <a:grpFill/>
           </p:spPr>
           <p:txBody>
             <a:bodyPr wrap="none" rtlCol="0">
@@ -11955,7 +11815,7 @@
             <a:prstGeom prst="rect">
               <a:avLst/>
             </a:prstGeom>
-            <a:noFill/>
+            <a:grpFill/>
             <a:extLst>
               <a:ext uri="{909E8E84-426E-40DD-AFC4-6F175D3DCCD1}">
                 <a14:hiddenFill xmlns:a14="http://schemas.microsoft.com/office/drawing/2010/main">

</xml_diff>